<commit_message>
Evaluacion: dejar el componente abierto como "Talleres o Quiz"
El 10% del corte se nombraba distinto segun el documento: "Talleres y Quiz" en
los Acuerdos y "Talleres / Quiz" en las diapositivas. La "y" obligaba a que
contaran ambos; ahora queda explicitamente abierto ("o"), que es como el docente
lo aplica: el 10% se puede componer de talleres, de quices, o de ambos.

Unificado en los 4 cursos: Presentaciones del Curso, Acuerdos Pedagogicos,
LEEME y los builders (incluido gen_builds.py, para que un curso nuevo nazca
con la misma redaccion).

Co-Authored-By: Claude Opus 5 <noreply@anthropic.com>
</commit_message>
<xml_diff>
--- a/Arquitectura de Sistemas Computacionales/Clases/Presentacion del Curso - Arquitectura de Sistemas Computacionales.pptx
+++ b/Arquitectura de Sistemas Computacionales/Clases/Presentacion del Curso - Arquitectura de Sistemas Computacionales.pptx
@@ -7543,7 +7543,7 @@
                 </a:solidFill>
                 <a:latin typeface="Calibri"/>
               </a:rPr>
-              <a:t>–   Talleres / Quiz · 10%</a:t>
+              <a:t>–   Talleres o Quiz · 10%</a:t>
             </a:r>
           </a:p>
           <a:p>
@@ -7823,7 +7823,7 @@
                 </a:solidFill>
                 <a:latin typeface="Calibri"/>
               </a:rPr>
-              <a:t>–   Talleres / Quiz · 10%</a:t>
+              <a:t>–   Talleres o Quiz · 10%</a:t>
             </a:r>
           </a:p>
           <a:p>

</xml_diff>